<commit_message>
Keep the two-page thesis to market indicators only
Remove every product and strategy reference (ETF weights, coupons, fair
coupon, autocall); page 2 now covers the Fed path, bond rate risk and
record equity volatility.

Co-Authored-By: Claude Opus 5.5 <noreply@anthropic.com>
Claude-Session: https://claude.ai/code/session_01Rwoh8cFDQqLD8JWT3mee6y
</commit_message>
<xml_diff>
--- a/deck/Investment-Thesis-TwoPages.pptx
+++ b/deck/Investment-Thesis-TwoPages.pptx
@@ -1043,7 +1043,7 @@
                 </a:solidFill>
                 <a:latin typeface="Arial"/>
               </a:rPr>
-              <a:t>Income on USD 100, % a year</a:t>
+              <a:t>5Y USD bond price change vs rate move</a:t>
             </a:r>
           </a:p>
         </c:rich>
@@ -1067,26 +1067,26 @@
               <c:strCache>
                 <c:ptCount val="1"/>
                 <c:pt idx="0">
-                  <c:v>% a year</c:v>
+                  <c:v>5Y USD bond</c:v>
                 </c:pt>
               </c:strCache>
             </c:strRef>
           </c:tx>
           <c:spPr>
             <a:solidFill>
-              <a:srgbClr val="A6A6A6"/>
+              <a:srgbClr val="2C5F82"/>
             </a:solidFill>
             <a:effectLst/>
           </c:spPr>
           <c:invertIfNegative val="0"/>
           <c:dLbls>
-            <c:numFmt formatCode="0.00&quot;%&quot;" sourceLinked="0"/>
+            <c:numFmt formatCode="+0.0&quot;%&quot;;−0.0&quot;%&quot;;0" sourceLinked="0"/>
             <c:txPr>
               <a:bodyPr/>
               <a:lstStyle/>
               <a:p>
                 <a:pPr>
-                  <a:defRPr b="0" i="0" strike="noStrike" sz="850" u="none">
+                  <a:defRPr b="0" i="0" strike="noStrike" sz="800" u="none">
                     <a:solidFill>
                       <a:srgbClr val="262626"/>
                     </a:solidFill>
@@ -1103,53 +1103,26 @@
             <c:showBubbleSize val="0"/>
             <c:showLeaderLines val="0"/>
           </c:dLbls>
-          <c:dPt>
-            <c:idx val="0"/>
-            <c:invertIfNegative val="0"/>
-            <c:bubble3D val="0"/>
-            <c:spPr>
-              <a:solidFill>
-                <a:srgbClr val="A6A6A6"/>
-              </a:solidFill>
-              <a:effectLst/>
-            </c:spPr>
-          </c:dPt>
-          <c:dPt>
-            <c:idx val="1"/>
-            <c:invertIfNegative val="0"/>
-            <c:bubble3D val="0"/>
-            <c:spPr>
-              <a:solidFill>
-                <a:srgbClr val="2C5F82"/>
-              </a:solidFill>
-              <a:effectLst/>
-            </c:spPr>
-          </c:dPt>
-          <c:dPt>
-            <c:idx val="2"/>
-            <c:invertIfNegative val="0"/>
-            <c:bubble3D val="0"/>
-            <c:spPr>
-              <a:solidFill>
-                <a:srgbClr val="8DB3D1"/>
-              </a:solidFill>
-              <a:effectLst/>
-            </c:spPr>
-          </c:dPt>
           <c:cat>
             <c:multiLvlStrRef>
-              <c:f>Sheet1!$A$2:$A$4</c:f>
+              <c:f>Sheet1!$A$2:$A$6</c:f>
               <c:multiLvlStrCache>
-                <c:ptCount val="3"/>
+                <c:ptCount val="5"/>
                 <c:lvl>
                   <c:pt idx="0">
-                    <c:v>5Y USD rate</c:v>
+                    <c:v>−2%</c:v>
                   </c:pt>
                   <c:pt idx="1">
-                    <c:v>Client coupon</c:v>
+                    <c:v>−1%</c:v>
                   </c:pt>
                   <c:pt idx="2">
-                    <c:v>Fair coupon</c:v>
+                    <c:v>0</c:v>
+                  </c:pt>
+                  <c:pt idx="3">
+                    <c:v>+1%</c:v>
+                  </c:pt>
+                  <c:pt idx="4">
+                    <c:v>+2%</c:v>
                   </c:pt>
                 </c:lvl>
               </c:multiLvlStrCache>
@@ -1157,31 +1130,37 @@
           </c:cat>
           <c:val>
             <c:numRef>
-              <c:f>Sheet1!$B$2:$B$4</c:f>
+              <c:f>Sheet1!$B$2:$B$6</c:f>
               <c:numCache>
                 <c:formatCode>General</c:formatCode>
-                <c:ptCount val="3"/>
+                <c:ptCount val="5"/>
                 <c:pt idx="0">
-                  <c:v>5.69</c:v>
+                  <c:v>9.1</c:v>
                 </c:pt>
                 <c:pt idx="1">
-                  <c:v>10</c:v>
+                  <c:v>4.5</c:v>
                 </c:pt>
                 <c:pt idx="2">
-                  <c:v>13.75</c:v>
+                  <c:v>0</c:v>
+                </c:pt>
+                <c:pt idx="3">
+                  <c:v>-4</c:v>
+                </c:pt>
+                <c:pt idx="4">
+                  <c:v>-7.9</c:v>
                 </c:pt>
               </c:numCache>
             </c:numRef>
           </c:val>
         </c:ser>
         <c:dLbls>
-          <c:numFmt formatCode="0.00&quot;%&quot;" sourceLinked="0"/>
+          <c:numFmt formatCode="+0.0&quot;%&quot;;−0.0&quot;%&quot;;0" sourceLinked="0"/>
           <c:txPr>
             <a:bodyPr/>
             <a:lstStyle/>
             <a:p>
               <a:pPr>
-                <a:defRPr b="0" i="0" strike="noStrike" sz="850" u="none">
+                <a:defRPr b="0" i="0" strike="noStrike" sz="800" u="none">
                   <a:solidFill>
                     <a:srgbClr val="262626"/>
                   </a:solidFill>
@@ -1249,8 +1228,8 @@
         <c:axId val="2094734552"/>
         <c:scaling>
           <c:orientation val="minMax"/>
-          <c:max val="16"/>
-          <c:min val="0"/>
+          <c:max val="12"/>
+          <c:min val="-12"/>
         </c:scaling>
         <c:delete val="1"/>
         <c:axPos val="l"/>
@@ -1705,7 +1684,7 @@
           <a:p>
             <a:r>
               <a:rPr lang="en-US" dirty="0"/>
-              <a:t>Thesis 1, what we own. AI spending is a hardware boom and Asia holds the three bottlenecks: Taiwan's foundries, Korea's high-bandwidth memory, Japan's chip-making tools; each maps to an ETF in the basket. The demand is structural, but the memory cycle is maturing and the indices that hold the theme move violently: KOSPI lost about a quarter between June and August. Returns are concentrated in a few names and valuations are full, which is why we hold a diversified basket and take the return as coupons rather than buying outright.</a:t>
+              <a:t>Thesis 1, the theme. AI spending is a hardware boom and Asia holds the three bottlenecks: Taiwan's foundries, Korea's high-bandwidth memory, Japan's chip-making tools. The demand is structural, but the memory cycle is maturing and the indices that hold the theme move violently: KOSPI lost about a quarter between June and August. Returns are concentrated in a few names and valuations are full.</a:t>
             </a:r>
             <a:endParaRPr lang="en-US" dirty="0"/>
           </a:p>
@@ -1793,7 +1772,7 @@
           <a:p>
             <a:r>
               <a:rPr lang="en-US" dirty="0"/>
-              <a:t>Thesis 2, why an autocall now. The Fed's dot plot keeps the median at 4.125% to end-2027 with cuts only from 2028, and it has just hiked, so a long bond carries real rate risk (about 4.0% per 1% rise). The autocall can redeem from year 1, so its duration is short. Volatility is at records, and in an autocall the client sells options on the basket, so rich option premium plus high rates fund a fair coupon of 13.75% a year. We pay the client 10% and keep 3.75% a year.</a:t>
+              <a:t>Thesis 2, the backdrop. The Fed's dot plot keeps the median at 4.125% to end-2027 with cuts only from 2028; it has just hiked and futures price more. Yields are high, but a long bond loses about 4.0% per 1% rise, so duration is a risk. Asian equity volatility is at records: VKOSPI hit 91.2 and KOSPI fell nearly 9% in one day. Both bonds and buy-and-hold carry more risk than usual.</a:t>
             </a:r>
             <a:endParaRPr lang="en-US" dirty="0"/>
           </a:p>
@@ -2426,7 +2405,7 @@
                 <a:ea typeface="Arial" pitchFamily="34" charset="-122"/>
                 <a:cs typeface="Arial" pitchFamily="34" charset="-120"/>
               </a:rPr>
-              <a:t>What we own: structural demand for Asian chips, memory and tools, bought in markets that are concentrated, fully priced and violent</a:t>
+              <a:t>The theme: structural demand for Asian chips, memory and tools, traded in markets that are concentrated, fully priced and violent</a:t>
             </a:r>
             <a:endParaRPr lang="en-US" sz="1050" dirty="0"/>
           </a:p>
@@ -2830,7 +2809,7 @@
                 <a:ea typeface="Arial" pitchFamily="34" charset="-122"/>
                 <a:cs typeface="Arial" pitchFamily="34" charset="-120"/>
               </a:rPr>
-              <a:t>→ EWT 15% and 00878 TT 15%</a:t>
+              <a:t>→ Taiwan is the single largest AI chokepoint</a:t>
             </a:r>
             <a:endParaRPr lang="en-US" sz="900" dirty="0"/>
           </a:p>
@@ -2998,7 +2977,7 @@
                 <a:ea typeface="Arial" pitchFamily="34" charset="-122"/>
                 <a:cs typeface="Arial" pitchFamily="34" charset="-120"/>
               </a:rPr>
-              <a:t>→ EWY 20%</a:t>
+              <a:t>→ No AI accelerator ships without Korean memory</a:t>
             </a:r>
             <a:endParaRPr lang="en-US" sz="900" dirty="0"/>
           </a:p>
@@ -3166,7 +3145,7 @@
                 <a:ea typeface="Arial" pitchFamily="34" charset="-122"/>
                 <a:cs typeface="Arial" pitchFamily="34" charset="-120"/>
               </a:rPr>
-              <a:t>→ 2644 JP 15%; 3119 HK 35% spans the region</a:t>
+              <a:t>→ Every new fab needs Japanese tools</a:t>
             </a:r>
             <a:endParaRPr lang="en-US" sz="900" dirty="0"/>
           </a:p>
@@ -3362,7 +3341,7 @@
                 <a:ea typeface="Arial" pitchFamily="34" charset="-122"/>
                 <a:cs typeface="Arial" pitchFamily="34" charset="-120"/>
               </a:rPr>
-              <a:t>Down 10–25% in 2022; KOSPI fell 8.95% in a single day (13 Jul 2026).</a:t>
+              <a:t>Down 10–25% in 2022; records in June 2026, then sharp falls within weeks.</a:t>
             </a:r>
             <a:endParaRPr lang="en-US" sz="950" dirty="0"/>
           </a:p>
@@ -3510,7 +3489,7 @@
                 <a:ea typeface="Arial" pitchFamily="34" charset="-122"/>
                 <a:cs typeface="Arial" pitchFamily="34" charset="-120"/>
               </a:rPr>
-              <a:t>KOSPI went from 9,000+ in June to 6,789 on 28 Aug; J.P. Morgan expects a 10–15% correction in 2026.</a:t>
+              <a:t>KOSPI went from 9,000+ in June to 6,789 on 28 Aug 2026, in about ten weeks.</a:t>
             </a:r>
             <a:endParaRPr lang="en-US" sz="900" dirty="0"/>
           </a:p>
@@ -3530,7 +3509,7 @@
                 <a:ea typeface="Arial" pitchFamily="34" charset="-122"/>
                 <a:cs typeface="Arial" pitchFamily="34" charset="-120"/>
               </a:rPr>
-              <a:t>→ Buying in one go is risky: the note pays on recovery, no timing needed</a:t>
+              <a:t>→ Entry timing is hard; drawdowns are deep and quick</a:t>
             </a:r>
             <a:endParaRPr lang="en-US" sz="900" dirty="0"/>
           </a:p>
@@ -3698,7 +3677,7 @@
                 <a:ea typeface="Arial" pitchFamily="34" charset="-122"/>
                 <a:cs typeface="Arial" pitchFamily="34" charset="-120"/>
               </a:rPr>
-              <a:t>→ Diversified five-ETF basket, not a worst-of on single names</a:t>
+              <a:t>→ Single-name risk is high</a:t>
             </a:r>
             <a:endParaRPr lang="en-US" sz="900" dirty="0"/>
           </a:p>
@@ -3866,7 +3845,7 @@
                 <a:ea typeface="Arial" pitchFamily="34" charset="-122"/>
                 <a:cs typeface="Arial" pitchFamily="34" charset="-120"/>
               </a:rPr>
-              <a:t>→ Coupons lock in gains if the rally stalls</a:t>
+              <a:t>→ Upside from here is less certain than the theme</a:t>
             </a:r>
             <a:endParaRPr lang="en-US" sz="900" dirty="0"/>
           </a:p>
@@ -4040,7 +4019,7 @@
                 <a:ea typeface="Arial" pitchFamily="34" charset="-122"/>
                 <a:cs typeface="Arial" pitchFamily="34" charset="-120"/>
               </a:rPr>
-              <a:t>Investment thesis 2: High rates and record volatility favour an autocall</a:t>
+              <a:t>Investment thesis 2: Rates stay high and volatility is at records</a:t>
             </a:r>
             <a:endParaRPr lang="en-US" sz="2200" dirty="0"/>
           </a:p>
@@ -4267,7 +4246,7 @@
                 <a:ea typeface="Arial" pitchFamily="34" charset="-122"/>
                 <a:cs typeface="Arial" pitchFamily="34" charset="-120"/>
               </a:rPr>
-              <a:t>Why we wrap it: rates stay high, so bonds carry rate risk; volatility is at records, so the option the client sells is worth more than ever</a:t>
+              <a:t>The backdrop for the next five years: the Fed holds rates high, bonds carry rate risk, and Asian equities swing harder than ever</a:t>
             </a:r>
             <a:endParaRPr lang="en-US" sz="1050" dirty="0"/>
           </a:p>
@@ -4345,7 +4324,7 @@
                 <a:ea typeface="Arial" pitchFamily="34" charset="-122"/>
                 <a:cs typeface="Arial" pitchFamily="34" charset="-120"/>
               </a:rPr>
-              <a:t>Rates stay high for longer</a:t>
+              <a:t>The Fed holds rates high for longer</a:t>
             </a:r>
             <a:endParaRPr lang="en-US" sz="1250" dirty="0"/>
           </a:p>
@@ -4724,7 +4703,7 @@
                 <a:ea typeface="Arial" pitchFamily="34" charset="-122"/>
                 <a:cs typeface="Arial" pitchFamily="34" charset="-120"/>
               </a:rPr>
-              <a:t>16 Sep 2026: to 3.75–4.00%, the first hike since 2023; futures price ~87% odds of at least one more.</a:t>
+              <a:t>16 Sep 2026: to 3.75–4.00%, the first hike since 2023.</a:t>
             </a:r>
             <a:endParaRPr lang="en-US" sz="900" dirty="0"/>
           </a:p>
@@ -4744,7 +4723,7 @@
                 <a:ea typeface="Arial" pitchFamily="34" charset="-122"/>
                 <a:cs typeface="Arial" pitchFamily="34" charset="-120"/>
               </a:rPr>
-              <a:t>→ Locking in a long fixed rate now is not attractive</a:t>
+              <a:t>→ The easing cycle is over for now</a:t>
             </a:r>
             <a:endParaRPr lang="en-US" sz="900" dirty="0"/>
           </a:p>
@@ -4833,7 +4812,7 @@
                 <a:ea typeface="Arial" pitchFamily="34" charset="-122"/>
                 <a:cs typeface="Arial" pitchFamily="34" charset="-120"/>
               </a:rPr>
-              <a:t>−4.0%</a:t>
+              <a:t>~87%</a:t>
             </a:r>
             <a:endParaRPr lang="en-US" sz="1700" dirty="0"/>
           </a:p>
@@ -4875,7 +4854,7 @@
                 <a:ea typeface="Arial" pitchFamily="34" charset="-122"/>
                 <a:cs typeface="Arial" pitchFamily="34" charset="-120"/>
               </a:rPr>
-              <a:t>Long bonds carry rate risk: </a:t>
+              <a:t>Markets price more: </a:t>
             </a:r>
             <a:pPr indent="0" marL="0">
               <a:spcAft>
@@ -4892,7 +4871,7 @@
                 <a:ea typeface="Arial" pitchFamily="34" charset="-122"/>
                 <a:cs typeface="Arial" pitchFamily="34" charset="-120"/>
               </a:rPr>
-              <a:t>a 5-year bond loses ~4.0% per 1% rise in rates.</a:t>
+              <a:t>probability of at least one further hike priced by fed funds futures.</a:t>
             </a:r>
             <a:endParaRPr lang="en-US" sz="900" dirty="0"/>
           </a:p>
@@ -4912,7 +4891,7 @@
                 <a:ea typeface="Arial" pitchFamily="34" charset="-122"/>
                 <a:cs typeface="Arial" pitchFamily="34" charset="-120"/>
               </a:rPr>
-              <a:t>→ The note can redeem from year 1: short duration, cash back to reinvest higher</a:t>
+              <a:t>→ Risk to rates is still to the upside</a:t>
             </a:r>
             <a:endParaRPr lang="en-US" sz="900" dirty="0"/>
           </a:p>
@@ -4990,7 +4969,7 @@
                 <a:ea typeface="Arial" pitchFamily="34" charset="-122"/>
                 <a:cs typeface="Arial" pitchFamily="34" charset="-120"/>
               </a:rPr>
-              <a:t>Record volatility pays the coupon</a:t>
+              <a:t>Bonds carry rate risk, equities swing hard</a:t>
             </a:r>
             <a:endParaRPr lang="en-US" sz="1250" dirty="0"/>
           </a:p>
@@ -5048,7 +5027,7 @@
                 <a:ea typeface="Arial" pitchFamily="34" charset="-122"/>
                 <a:cs typeface="Arial" pitchFamily="34" charset="-120"/>
               </a:rPr>
-              <a:t>Volatility is the client's to sell</a:t>
+              <a:t>Yields are high…</a:t>
             </a:r>
             <a:endParaRPr lang="en-US" sz="950" dirty="0"/>
           </a:p>
@@ -5068,7 +5047,7 @@
                 <a:ea typeface="Arial" pitchFamily="34" charset="-122"/>
                 <a:cs typeface="Arial" pitchFamily="34" charset="-120"/>
               </a:rPr>
-              <a:t>In an autocall the client sells options on the basket; the higher the volatility, the more they are worth.</a:t>
+              <a:t>5Y USD at 5.69%: high income on offer.</a:t>
             </a:r>
             <a:endParaRPr lang="en-US" sz="950" dirty="0"/>
           </a:p>
@@ -5082,13 +5061,13 @@
             <a:r>
               <a:rPr lang="en-US" sz="950" b="1" dirty="0">
                 <a:solidFill>
-                  <a:srgbClr val="2C5F82"/>
-                </a:solidFill>
-                <a:latin typeface="Arial" pitchFamily="34" charset="0"/>
-                <a:ea typeface="Arial" pitchFamily="34" charset="-122"/>
-                <a:cs typeface="Arial" pitchFamily="34" charset="-120"/>
-              </a:rPr>
-              <a:t>High rates add to it</a:t>
+                  <a:srgbClr val="B23B3B"/>
+                </a:solidFill>
+                <a:latin typeface="Arial" pitchFamily="34" charset="0"/>
+                <a:ea typeface="Arial" pitchFamily="34" charset="-122"/>
+                <a:cs typeface="Arial" pitchFamily="34" charset="-120"/>
+              </a:rPr>
+              <a:t>…but prices are exposed</a:t>
             </a:r>
             <a:endParaRPr lang="en-US" sz="950" dirty="0"/>
           </a:p>
@@ -5108,7 +5087,7 @@
                 <a:ea typeface="Arial" pitchFamily="34" charset="-122"/>
                 <a:cs typeface="Arial" pitchFamily="34" charset="-120"/>
               </a:rPr>
-              <a:t>At 5.69% 5Y USD funding, the forward drift and discounting raise the coupon the note can pay.</a:t>
+              <a:t>With hikes back on the table, a fixed rate locked in today loses value if rates rise further.</a:t>
             </a:r>
             <a:endParaRPr lang="en-US" sz="950" dirty="0"/>
           </a:p>
@@ -5154,11 +5133,11 @@
             <a:avLst/>
           </a:prstGeom>
           <a:solidFill>
-            <a:srgbClr val="B23B3B"/>
+            <a:srgbClr val="2C5F82"/>
           </a:solidFill>
           <a:ln w="12700">
             <a:solidFill>
-              <a:srgbClr val="B23B3B"/>
+              <a:srgbClr val="2C5F82"/>
             </a:solidFill>
             <a:prstDash val="solid"/>
           </a:ln>
@@ -5191,13 +5170,13 @@
             <a:r>
               <a:rPr lang="en-US" sz="1700" b="1" dirty="0">
                 <a:solidFill>
-                  <a:srgbClr val="B23B3B"/>
-                </a:solidFill>
-                <a:latin typeface="Arial" pitchFamily="34" charset="0"/>
-                <a:ea typeface="Arial" pitchFamily="34" charset="-122"/>
-                <a:cs typeface="Arial" pitchFamily="34" charset="-120"/>
-              </a:rPr>
-              <a:t>91.2</a:t>
+                  <a:srgbClr val="2C5F82"/>
+                </a:solidFill>
+                <a:latin typeface="Arial" pitchFamily="34" charset="0"/>
+                <a:ea typeface="Arial" pitchFamily="34" charset="-122"/>
+                <a:cs typeface="Arial" pitchFamily="34" charset="-120"/>
+              </a:rPr>
+              <a:t>−4.0%</a:t>
             </a:r>
             <a:endParaRPr lang="en-US" sz="1700" dirty="0"/>
           </a:p>
@@ -5239,7 +5218,7 @@
                 <a:ea typeface="Arial" pitchFamily="34" charset="-122"/>
                 <a:cs typeface="Arial" pitchFamily="34" charset="-120"/>
               </a:rPr>
-              <a:t>Volatility is at records: </a:t>
+              <a:t>Long bonds carry rate risk: </a:t>
             </a:r>
             <a:pPr indent="0" marL="0">
               <a:spcAft>
@@ -5256,7 +5235,7 @@
                 <a:ea typeface="Arial" pitchFamily="34" charset="-122"/>
                 <a:cs typeface="Arial" pitchFamily="34" charset="-120"/>
               </a:rPr>
-              <a:t>VKOSPI closed at an all-time high of 91.2 (9 Jun 2026), above the 2008 peak.</a:t>
+              <a:t>a 5-year bond loses ~4.0% per 1% rise in rates.</a:t>
             </a:r>
             <a:endParaRPr lang="en-US" sz="900" dirty="0"/>
           </a:p>
@@ -5276,7 +5255,7 @@
                 <a:ea typeface="Arial" pitchFamily="34" charset="-122"/>
                 <a:cs typeface="Arial" pitchFamily="34" charset="-120"/>
               </a:rPr>
-              <a:t>→ Rich option premium funds a coupon well above bonds</a:t>
+              <a:t>→ Duration is a risk, not a hedge, in this cycle</a:t>
             </a:r>
             <a:endParaRPr lang="en-US" sz="900" dirty="0"/>
           </a:p>
@@ -5322,11 +5301,11 @@
             <a:avLst/>
           </a:prstGeom>
           <a:solidFill>
-            <a:srgbClr val="2C5F82"/>
+            <a:srgbClr val="B23B3B"/>
           </a:solidFill>
           <a:ln w="12700">
             <a:solidFill>
-              <a:srgbClr val="2C5F82"/>
+              <a:srgbClr val="B23B3B"/>
             </a:solidFill>
             <a:prstDash val="solid"/>
           </a:ln>
@@ -5359,13 +5338,13 @@
             <a:r>
               <a:rPr lang="en-US" sz="1700" b="1" dirty="0">
                 <a:solidFill>
-                  <a:srgbClr val="2C5F82"/>
-                </a:solidFill>
-                <a:latin typeface="Arial" pitchFamily="34" charset="0"/>
-                <a:ea typeface="Arial" pitchFamily="34" charset="-122"/>
-                <a:cs typeface="Arial" pitchFamily="34" charset="-120"/>
-              </a:rPr>
-              <a:t>13.75%</a:t>
+                  <a:srgbClr val="B23B3B"/>
+                </a:solidFill>
+                <a:latin typeface="Arial" pitchFamily="34" charset="0"/>
+                <a:ea typeface="Arial" pitchFamily="34" charset="-122"/>
+                <a:cs typeface="Arial" pitchFamily="34" charset="-120"/>
+              </a:rPr>
+              <a:t>91.2</a:t>
             </a:r>
             <a:endParaRPr lang="en-US" sz="1700" dirty="0"/>
           </a:p>
@@ -5407,7 +5386,7 @@
                 <a:ea typeface="Arial" pitchFamily="34" charset="-122"/>
                 <a:cs typeface="Arial" pitchFamily="34" charset="-120"/>
               </a:rPr>
-              <a:t>Fair coupon a year: </a:t>
+              <a:t>Volatility is at records: </a:t>
             </a:r>
             <a:pPr indent="0" marL="0">
               <a:spcAft>
@@ -5424,7 +5403,7 @@
                 <a:ea typeface="Arial" pitchFamily="34" charset="-122"/>
                 <a:cs typeface="Arial" pitchFamily="34" charset="-120"/>
               </a:rPr>
-              <a:t>Monte Carlo value of the five-ETF annual step-down autocall at today's rates, vols and correlations.</a:t>
+              <a:t>VKOSPI closed at an all-time high of 91.2 (9 Jun 2026), above the 2008 peak.</a:t>
             </a:r>
             <a:endParaRPr lang="en-US" sz="900" dirty="0"/>
           </a:p>
@@ -5444,7 +5423,7 @@
                 <a:ea typeface="Arial" pitchFamily="34" charset="-122"/>
                 <a:cs typeface="Arial" pitchFamily="34" charset="-120"/>
               </a:rPr>
-              <a:t>→ Natixis keeps 3.75% a year for structuring and hedging</a:t>
+              <a:t>→ Option-implied risk in Asian equities is extreme</a:t>
             </a:r>
             <a:endParaRPr lang="en-US" sz="900" dirty="0"/>
           </a:p>
@@ -5490,11 +5469,11 @@
             <a:avLst/>
           </a:prstGeom>
           <a:solidFill>
-            <a:srgbClr val="2C5F82"/>
+            <a:srgbClr val="B23B3B"/>
           </a:solidFill>
           <a:ln w="12700">
             <a:solidFill>
-              <a:srgbClr val="2C5F82"/>
+              <a:srgbClr val="B23B3B"/>
             </a:solidFill>
             <a:prstDash val="solid"/>
           </a:ln>
@@ -5527,13 +5506,13 @@
             <a:r>
               <a:rPr lang="en-US" sz="1700" b="1" dirty="0">
                 <a:solidFill>
-                  <a:srgbClr val="2C5F82"/>
-                </a:solidFill>
-                <a:latin typeface="Arial" pitchFamily="34" charset="0"/>
-                <a:ea typeface="Arial" pitchFamily="34" charset="-122"/>
-                <a:cs typeface="Arial" pitchFamily="34" charset="-120"/>
-              </a:rPr>
-              <a:t>10%</a:t>
+                  <a:srgbClr val="B23B3B"/>
+                </a:solidFill>
+                <a:latin typeface="Arial" pitchFamily="34" charset="0"/>
+                <a:ea typeface="Arial" pitchFamily="34" charset="-122"/>
+                <a:cs typeface="Arial" pitchFamily="34" charset="-120"/>
+              </a:rPr>
+              <a:t>−8.95%</a:t>
             </a:r>
             <a:endParaRPr lang="en-US" sz="1700" dirty="0"/>
           </a:p>
@@ -5575,7 +5554,7 @@
                 <a:ea typeface="Arial" pitchFamily="34" charset="-122"/>
                 <a:cs typeface="Arial" pitchFamily="34" charset="-120"/>
               </a:rPr>
-              <a:t>Client coupon a year: </a:t>
+              <a:t>Single days move markets: </a:t>
             </a:r>
             <a:pPr indent="0" marL="0">
               <a:spcAft>
@@ -5592,7 +5571,7 @@
                 <a:ea typeface="Arial" pitchFamily="34" charset="-122"/>
                 <a:cs typeface="Arial" pitchFamily="34" charset="-120"/>
               </a:rPr>
-              <a:t>Paid when the basket is at or above the call level (102.5% in year 1, stepping down to 92.5% in year 5).</a:t>
+              <a:t>KOSPI's one-day fall on 13 Jul 2026; J.P. Morgan expects a 10–15% correction in 2026.</a:t>
             </a:r>
             <a:endParaRPr lang="en-US" sz="900" dirty="0"/>
           </a:p>
@@ -5612,7 +5591,7 @@
                 <a:ea typeface="Arial" pitchFamily="34" charset="-122"/>
                 <a:cs typeface="Arial" pitchFamily="34" charset="-120"/>
               </a:rPr>
-              <a:t>→ Coupons pay while the market swings; 70% barrier checked at maturity only</a:t>
+              <a:t>→ Buy-and-hold must sit through deep drawdowns</a:t>
             </a:r>
             <a:endParaRPr lang="en-US" sz="900" dirty="0"/>
           </a:p>
@@ -5676,7 +5655,7 @@
                 <a:ea typeface="Arial" pitchFamily="34" charset="-122"/>
                 <a:cs typeface="Arial" pitchFamily="34" charset="-120"/>
               </a:rPr>
-              <a:t>Rates and volatility make the option the client sells valuable: we turn it into a 10% coupon on Asia's AI hardware.</a:t>
+              <a:t>Rates stay high for longer and Asian equity volatility is at records: neither bonds nor buy-and-hold are a comfortable place to sit.</a:t>
             </a:r>
             <a:endParaRPr lang="en-US" sz="1150" dirty="0"/>
           </a:p>
@@ -5715,7 +5694,7 @@
                 <a:ea typeface="Arial" pitchFamily="34" charset="-122"/>
                 <a:cs typeface="Arial" pitchFamily="34" charset="-120"/>
               </a:rPr>
-              <a:t>Sources: Federal Reserve SEP (16 Sep 2026, dots read from chart); Federal Reserve via Advisor Perspectives; fed funds futures; Herald / SBS (VKOSPI); case USD funding grid (5Y 5.69%); standard bond maths; team Monte Carlo pricing (Appendix E: fair coupon 13.752219%).</a:t>
+              <a:t>Sources: Federal Reserve SEP (16 Sep 2026, dots read from chart); Federal Reserve via Advisor Perspectives; fed funds futures; case USD funding grid (5Y 5.69%); standard bond maths; Herald / SBS (VKOSPI); FN News, BIT Research (KOSPI); J.P. Morgan AWM 2026 Outlook.</a:t>
             </a:r>
             <a:endParaRPr lang="en-US" sz="750" dirty="0"/>
           </a:p>

</xml_diff>